<commit_message>
Fix the worktree exercise: the second folder gets the other branch
A branch can only be checked out in one worktree at a time, so asking for a
worktree on main while standing on main fails with:

    fatal: 'main' is already used by worktree at ...

The exercise now puts greeting-na in the new folder instead, which also makes
the demo better: the original folder shows 'Good afternoon, Europe' and the
worktree shows 'Hello North America', side by side. Verified in a dry run.

Co-Authored-By: Claude Opus 5 <noreply@anthropic.com>
Claude-Session: https://claude.ai/code/session_01UxYzx8xFMXZ75jT3GJXyKh
</commit_message>
<xml_diff>
--- a/01_GitTutorial/HowToGit - hands on.pptx
+++ b/01_GitTutorial/HowToGit - hands on.pptx
@@ -646,7 +646,7 @@
           <a:lstStyle/>
           <a:p>
             <a:r>
-              <a:t>Keep the worktree NEXT to the repo folder, never inside it. If GitHub Desktop is older than 3.6 there is no Worktree menu - use git worktree add ../gitintro-main main in the command line.</a:t>
+              <a:t>Verified in a dry run: asking for a worktree on 'main' while standing on main fails with "'main' is already used by worktree at ...". Always put the OTHER branch in the new folder. Keep it next to the repo, never inside it.</a:t>
             </a:r>
           </a:p>
         </p:txBody>
@@ -15544,46 +15544,8 @@
           <a:p>
             <a:pPr/>
             <a:r>
-              <a:rPr b="1" sz="1600"/>
-              <a:t>GitHub Desktop ▸ Repository ▸ New Worktree…</a:t>
-            </a:r>
-          </a:p>
-          <a:p>
-            <a:pPr lvl="1"/>
-            <a:r>
-              <a:rPr sz="1500"/>
-              <a:t>Name: </a:t>
-            </a:r>
-            <a:r>
-              <a:rPr sz="1500">
-                <a:latin typeface="Consolas"/>
-              </a:rPr>
-              <a:t>gitintro-main</a:t>
-            </a:r>
-            <a:r>
-              <a:rPr sz="1500"/>
-              <a:t>, Branch: </a:t>
-            </a:r>
-            <a:r>
-              <a:rPr sz="1500">
-                <a:latin typeface="Consolas"/>
-              </a:rPr>
-              <a:t>main</a:t>
-            </a:r>
-          </a:p>
-          <a:p>
-            <a:pPr/>
-            <a:r>
               <a:rPr sz="1600"/>
-              <a:t>You now have a </a:t>
-            </a:r>
-            <a:r>
-              <a:rPr b="1" sz="1600"/>
-              <a:t>second folder on disk</a:t>
-            </a:r>
-            <a:r>
-              <a:rPr sz="1600"/>
-              <a:t>, sitting on </a:t>
+              <a:t>You are standing on </a:t>
             </a:r>
             <a:r>
               <a:rPr sz="1600">
@@ -15593,49 +15555,101 @@
             </a:r>
             <a:r>
               <a:rPr sz="1600"/>
-              <a:t>, sharing one repository</a:t>
-            </a:r>
-          </a:p>
-          <a:p>
-            <a:pPr/>
+              <a:t>. Put </a:t>
+            </a:r>
+            <a:r>
+              <a:rPr sz="1600">
+                <a:latin typeface="Consolas"/>
+              </a:rPr>
+              <a:t>greeting-na</a:t>
+            </a:r>
             <a:r>
               <a:rPr sz="1600"/>
-              <a:t>Open both folders side by side — two VS Code or MATLAB windows</a:t>
+              <a:t> into a </a:t>
+            </a:r>
+            <a:r>
+              <a:rPr b="1" sz="1600"/>
+              <a:t>second folder</a:t>
+            </a:r>
+            <a:r>
+              <a:rPr sz="1600"/>
+              <a:t>:</a:t>
             </a:r>
           </a:p>
           <a:p>
             <a:pPr lvl="1"/>
             <a:r>
+              <a:rPr b="1" sz="1500"/>
+              <a:t>Repository ▸ New Worktree…</a:t>
+            </a:r>
+            <a:r>
               <a:rPr sz="1500"/>
-              <a:t>Two </a:t>
+              <a:t>  →  Name: </a:t>
             </a:r>
             <a:r>
               <a:rPr sz="1500">
                 <a:latin typeface="Consolas"/>
               </a:rPr>
-              <a:t>readme.md</a:t>
+              <a:t>gitintro-na</a:t>
             </a:r>
             <a:r>
               <a:rPr sz="1500"/>
-              <a:t> files, two greetings, at the same time</a:t>
+              <a:t>, Branch: </a:t>
+            </a:r>
+            <a:r>
+              <a:rPr sz="1500">
+                <a:latin typeface="Consolas"/>
+              </a:rPr>
+              <a:t>greeting-na</a:t>
+            </a:r>
+          </a:p>
+          <a:p>
+            <a:pPr lvl="1"/>
+            <a:r>
+              <a:rPr sz="1500"/>
+              <a:t>Command line: </a:t>
+            </a:r>
+            <a:r>
+              <a:rPr sz="1500">
+                <a:latin typeface="Consolas"/>
+              </a:rPr>
+              <a:t>git worktree add ../gitintro-na greeting-na</a:t>
             </a:r>
           </a:p>
           <a:p>
             <a:pPr/>
             <a:r>
               <a:rPr sz="1600"/>
-              <a:t>Commit in either one. It is the same history.</a:t>
-            </a:r>
-          </a:p>
-          <a:p>
-            <a:pPr/>
-            <a:r>
-              <a:rPr sz="1600"/>
-              <a:t>When you are done: right-click the worktree ▸ </a:t>
-            </a:r>
-            <a:r>
-              <a:rPr b="1" sz="1600"/>
-              <a:t>Delete</a:t>
+              <a:t>Open both folders side by side — two VS Code or MATLAB windows</a:t>
+            </a:r>
+          </a:p>
+          <a:p>
+            <a:pPr lvl="1"/>
+            <a:r>
+              <a:rPr sz="1500"/>
+              <a:t>The original folder says </a:t>
+            </a:r>
+            <a:r>
+              <a:rPr b="1" sz="1500"/>
+              <a:t>“Good afternoon, Europe”</a:t>
+            </a:r>
+          </a:p>
+          <a:p>
+            <a:pPr lvl="1"/>
+            <a:r>
+              <a:rPr sz="1500"/>
+              <a:t>The new folder says </a:t>
+            </a:r>
+            <a:r>
+              <a:rPr b="1" sz="1500"/>
+              <a:t>“Hello North America”</a:t>
+            </a:r>
+          </a:p>
+          <a:p>
+            <a:pPr lvl="1"/>
+            <a:r>
+              <a:rPr sz="1500"/>
+              <a:t>Same repository, same history, two working copies</a:t>
             </a:r>
           </a:p>
           <a:p>
@@ -15647,7 +15661,52 @@
             <a:pPr/>
             <a:r>
               <a:rPr b="1" sz="1600"/>
-              <a:t>Why you will use this for real:</a:t>
+              <a:t>Why the new folder gets `greeting-na` and not `main`:</a:t>
+            </a:r>
+            <a:r>
+              <a:rPr sz="1600"/>
+              <a:t> a branch can be checked out in only </a:t>
+            </a:r>
+            <a:r>
+              <a:rPr b="1" sz="1600"/>
+              <a:t>one</a:t>
+            </a:r>
+            <a:r>
+              <a:rPr sz="1600"/>
+              <a:t> worktree at a time, and </a:t>
+            </a:r>
+            <a:r>
+              <a:rPr sz="1600">
+                <a:latin typeface="Consolas"/>
+              </a:rPr>
+              <a:t>main</a:t>
+            </a:r>
+            <a:r>
+              <a:rPr sz="1600"/>
+              <a:t> is already here.</a:t>
+            </a:r>
+          </a:p>
+          <a:p>
+            <a:pPr>
+              <a:defRPr sz="700"/>
+            </a:pPr>
+          </a:p>
+          <a:p>
+            <a:pPr/>
+            <a:r>
+              <a:rPr sz="1600"/>
+              <a:t>When you are done: right-click the worktree ▸ </a:t>
+            </a:r>
+            <a:r>
+              <a:rPr b="1" sz="1600"/>
+              <a:t>Delete</a:t>
+            </a:r>
+          </a:p>
+          <a:p>
+            <a:pPr/>
+            <a:r>
+              <a:rPr b="1" sz="1600"/>
+              <a:t>For real work:</a:t>
             </a:r>
             <a:r>
               <a:rPr sz="1600"/>
@@ -15667,7 +15726,7 @@
             </a:r>
             <a:r>
               <a:rPr sz="1600"/>
-              <a:t> model side by side in two sessions and diff the outputs.</a:t>
+              <a:t> model side by side and diff the outputs.</a:t>
             </a:r>
           </a:p>
         </p:txBody>

</xml_diff>